<commit_message>
Poster: deployed system numbers and the final over-the-air sweep
A0 and A4 posters (pptx, previews, A4 PDF) updated in place: PL latency 67.5 ms, +2.8 dB over the
JPEG + 802.11n LDPC baseline, PSNR-SNR curve and reconstruction grid from
data/measurements/psnr_snr/k0802_final (column SNR from the DeepJSCC-Q frames), 1.15 GMAC per frame,
routed resources of the deployed bitstreams, measured rails TX 3.07 W / RX 3.44 W.

Co-Authored-By: Claude Opus 5.5 <noreply@anthropic.com>
</commit_message>
<xml_diff>
--- a/report/poster/poster_en.pptx
+++ b/report/poster/poster_en.pptx
@@ -2799,7 +2799,15 @@
           <c:idx val="0"/>
           <c:order val="0"/>
           <c:tx>
-            <c:v>DeepJSCC-Q</c:v>
+            <c:strRef>
+              <c:f>Sheet1!$B$1</c:f>
+              <c:strCache>
+                <c:ptCount val="1"/>
+                <c:pt idx="0">
+                  <c:v>DeepJSCC-Q</c:v>
+                </c:pt>
+              </c:strCache>
+            </c:strRef>
           </c:tx>
           <c:spPr>
             <a:ln xmlns:a="http://schemas.openxmlformats.org/drawingml/2006/main" w="38100">
@@ -2819,192 +2827,228 @@
           </c:marker>
           <c:xVal>
             <c:numRef>
-              <c:f>'Chart Data'!$A$2:$A$30</c:f>
+              <c:f>Sheet1!$A$2:$A$36</c:f>
               <c:numCache>
                 <c:formatCode>General</c:formatCode>
-                <c:ptCount val="29"/>
+                <c:ptCount val="35"/>
                 <c:pt idx="0">
-                  <c:v>5.51</c:v>
+                  <c:v>2.94</c:v>
                 </c:pt>
                 <c:pt idx="1">
-                  <c:v>6.56</c:v>
+                  <c:v>4.94</c:v>
                 </c:pt>
                 <c:pt idx="2">
-                  <c:v>9.5</c:v>
+                  <c:v>5.9</c:v>
                 </c:pt>
                 <c:pt idx="3">
-                  <c:v>11.41</c:v>
+                  <c:v>7.03</c:v>
                 </c:pt>
                 <c:pt idx="4">
-                  <c:v>12.91</c:v>
+                  <c:v>8.43</c:v>
                 </c:pt>
                 <c:pt idx="5">
-                  <c:v>14.49</c:v>
+                  <c:v>9.3</c:v>
                 </c:pt>
                 <c:pt idx="6">
-                  <c:v>14.65</c:v>
+                  <c:v>10.49</c:v>
                 </c:pt>
                 <c:pt idx="7">
-                  <c:v>15.51</c:v>
+                  <c:v>11.48</c:v>
                 </c:pt>
                 <c:pt idx="8">
-                  <c:v>15.84</c:v>
+                  <c:v>12.48</c:v>
                 </c:pt>
                 <c:pt idx="9">
-                  <c:v>16.99</c:v>
+                  <c:v>13.02</c:v>
                 </c:pt>
                 <c:pt idx="10">
-                  <c:v>17.72</c:v>
+                  <c:v>13.74</c:v>
                 </c:pt>
                 <c:pt idx="11">
-                  <c:v>18.87</c:v>
+                  <c:v>14.18</c:v>
                 </c:pt>
                 <c:pt idx="12">
-                  <c:v>19.51</c:v>
+                  <c:v>15.76</c:v>
                 </c:pt>
                 <c:pt idx="13">
-                  <c:v>19.74</c:v>
+                  <c:v>16.33</c:v>
                 </c:pt>
                 <c:pt idx="14">
-                  <c:v>19.95</c:v>
+                  <c:v>17.03</c:v>
                 </c:pt>
                 <c:pt idx="15">
-                  <c:v>20.09</c:v>
+                  <c:v>17.36</c:v>
                 </c:pt>
                 <c:pt idx="16">
-                  <c:v>20.73</c:v>
+                  <c:v>17.38</c:v>
                 </c:pt>
                 <c:pt idx="17">
-                  <c:v>21.06</c:v>
+                  <c:v>18.45</c:v>
                 </c:pt>
                 <c:pt idx="18">
-                  <c:v>21.55</c:v>
+                  <c:v>18.91</c:v>
                 </c:pt>
                 <c:pt idx="19">
+                  <c:v>19.54</c:v>
+                </c:pt>
+                <c:pt idx="20">
+                  <c:v>19.68</c:v>
+                </c:pt>
+                <c:pt idx="21">
+                  <c:v>20.79</c:v>
+                </c:pt>
+                <c:pt idx="22">
+                  <c:v>21.31</c:v>
+                </c:pt>
+                <c:pt idx="23">
                   <c:v>22.48</c:v>
                 </c:pt>
-                <c:pt idx="20">
-                  <c:v>23.03</c:v>
-                </c:pt>
-                <c:pt idx="21">
-                  <c:v>23.66</c:v>
-                </c:pt>
-                <c:pt idx="22">
-                  <c:v>24.46</c:v>
-                </c:pt>
-                <c:pt idx="23">
-                  <c:v>26.13</c:v>
-                </c:pt>
                 <c:pt idx="24">
-                  <c:v>27.53</c:v>
+                  <c:v>23.1</c:v>
                 </c:pt>
                 <c:pt idx="25">
-                  <c:v>28.18</c:v>
+                  <c:v>23.24</c:v>
                 </c:pt>
                 <c:pt idx="26">
-                  <c:v>30.2</c:v>
+                  <c:v>24.49</c:v>
                 </c:pt>
                 <c:pt idx="27">
-                  <c:v>31.37</c:v>
+                  <c:v>26.5</c:v>
                 </c:pt>
                 <c:pt idx="28">
-                  <c:v>32.07</c:v>
+                  <c:v>27.69</c:v>
+                </c:pt>
+                <c:pt idx="29">
+                  <c:v>29.56</c:v>
+                </c:pt>
+                <c:pt idx="30">
+                  <c:v>31.97</c:v>
+                </c:pt>
+                <c:pt idx="31">
+                  <c:v>34.43</c:v>
+                </c:pt>
+                <c:pt idx="32">
+                  <c:v>35.2</c:v>
+                </c:pt>
+                <c:pt idx="33">
+                  <c:v>36.14</c:v>
+                </c:pt>
+                <c:pt idx="34">
+                  <c:v>36.49</c:v>
                 </c:pt>
               </c:numCache>
             </c:numRef>
           </c:xVal>
           <c:yVal>
             <c:numRef>
-              <c:f>'Chart Data'!$B$2:$B$30</c:f>
+              <c:f>Sheet1!$B$2:$B$36</c:f>
               <c:numCache>
-                <c:formatCode>0</c:formatCode>
-                <c:ptCount val="29"/>
+                <c:formatCode>General</c:formatCode>
+                <c:ptCount val="35"/>
                 <c:pt idx="0">
-                  <c:v>26.54</c:v>
+                  <c:v>23.51</c:v>
                 </c:pt>
                 <c:pt idx="1">
-                  <c:v>27.95</c:v>
+                  <c:v>25.58</c:v>
                 </c:pt>
                 <c:pt idx="2">
-                  <c:v>29.75</c:v>
+                  <c:v>26.94</c:v>
                 </c:pt>
                 <c:pt idx="3">
-                  <c:v>30.87</c:v>
+                  <c:v>28.22</c:v>
                 </c:pt>
                 <c:pt idx="4">
-                  <c:v>31.19</c:v>
+                  <c:v>29.1</c:v>
                 </c:pt>
                 <c:pt idx="5">
-                  <c:v>31.48</c:v>
+                  <c:v>29.77</c:v>
                 </c:pt>
                 <c:pt idx="6">
-                  <c:v>31.41</c:v>
+                  <c:v>30.4</c:v>
                 </c:pt>
                 <c:pt idx="7">
-                  <c:v>31.53</c:v>
+                  <c:v>30.72</c:v>
                 </c:pt>
                 <c:pt idx="8">
-                  <c:v>31.57</c:v>
+                  <c:v>30.96</c:v>
                 </c:pt>
                 <c:pt idx="9">
-                  <c:v>31.66</c:v>
+                  <c:v>31.01</c:v>
                 </c:pt>
                 <c:pt idx="10">
-                  <c:v>31.71</c:v>
+                  <c:v>31.22</c:v>
                 </c:pt>
                 <c:pt idx="11">
-                  <c:v>31.78</c:v>
+                  <c:v>31.46</c:v>
                 </c:pt>
                 <c:pt idx="12">
-                  <c:v>31.82</c:v>
+                  <c:v>31.49</c:v>
                 </c:pt>
                 <c:pt idx="13">
-                  <c:v>31.82</c:v>
+                  <c:v>31.68</c:v>
                 </c:pt>
                 <c:pt idx="14">
-                  <c:v>31.82</c:v>
+                  <c:v>31.74</c:v>
                 </c:pt>
                 <c:pt idx="15">
-                  <c:v>31.84</c:v>
+                  <c:v>31.79</c:v>
                 </c:pt>
                 <c:pt idx="16">
-                  <c:v>31.86</c:v>
+                  <c:v>31.8</c:v>
                 </c:pt>
                 <c:pt idx="17">
                   <c:v>31.87</c:v>
                 </c:pt>
                 <c:pt idx="18">
-                  <c:v>31.89</c:v>
+                  <c:v>31.91</c:v>
                 </c:pt>
                 <c:pt idx="19">
-                  <c:v>31.93</c:v>
+                  <c:v>31.94</c:v>
                 </c:pt>
                 <c:pt idx="20">
-                  <c:v>31.92</c:v>
+                  <c:v>31.95</c:v>
                 </c:pt>
                 <c:pt idx="21">
-                  <c:v>31.92</c:v>
+                  <c:v>32.0</c:v>
                 </c:pt>
                 <c:pt idx="22">
-                  <c:v>31.95</c:v>
+                  <c:v>32.03</c:v>
                 </c:pt>
                 <c:pt idx="23">
-                  <c:v>31.96</c:v>
+                  <c:v>32.07</c:v>
                 </c:pt>
                 <c:pt idx="24">
-                  <c:v>31.96</c:v>
+                  <c:v>32.09</c:v>
                 </c:pt>
                 <c:pt idx="25">
-                  <c:v>31.98</c:v>
+                  <c:v>32.1</c:v>
                 </c:pt>
                 <c:pt idx="26">
-                  <c:v>31.99</c:v>
+                  <c:v>32.13</c:v>
                 </c:pt>
                 <c:pt idx="27">
-                  <c:v>31.99</c:v>
+                  <c:v>32.16</c:v>
                 </c:pt>
                 <c:pt idx="28">
-                  <c:v>31.99</c:v>
+                  <c:v>32.17</c:v>
+                </c:pt>
+                <c:pt idx="29">
+                  <c:v>32.19</c:v>
+                </c:pt>
+                <c:pt idx="30">
+                  <c:v>32.2</c:v>
+                </c:pt>
+                <c:pt idx="31">
+                  <c:v>32.21</c:v>
+                </c:pt>
+                <c:pt idx="32">
+                  <c:v>32.21</c:v>
+                </c:pt>
+                <c:pt idx="33">
+                  <c:v>32.21</c:v>
+                </c:pt>
+                <c:pt idx="34">
+                  <c:v>32.21</c:v>
                 </c:pt>
               </c:numCache>
             </c:numRef>
@@ -3015,7 +3059,15 @@
           <c:idx val="1"/>
           <c:order val="1"/>
           <c:tx>
-            <c:v>SSCC</c:v>
+            <c:strRef>
+              <c:f>Sheet1!$B$38</c:f>
+              <c:strCache>
+                <c:ptCount val="1"/>
+                <c:pt idx="0">
+                  <c:v>SSCC</c:v>
+                </c:pt>
+              </c:strCache>
+            </c:strRef>
           </c:tx>
           <c:spPr>
             <a:ln xmlns:a="http://schemas.openxmlformats.org/drawingml/2006/main" w="38100">
@@ -3035,192 +3087,210 @@
           </c:marker>
           <c:xVal>
             <c:numRef>
-              <c:f>'Chart Data'!$C$2:$C$30</c:f>
+              <c:f>Sheet1!$A$39:$A$70</c:f>
               <c:numCache>
                 <c:formatCode>General</c:formatCode>
-                <c:ptCount val="29"/>
+                <c:ptCount val="32"/>
                 <c:pt idx="0">
-                  <c:v>5.4</c:v>
+                  <c:v>5.15</c:v>
                 </c:pt>
                 <c:pt idx="1">
-                  <c:v>6.9</c:v>
+                  <c:v>7.91</c:v>
                 </c:pt>
                 <c:pt idx="2">
-                  <c:v>7.82</c:v>
+                  <c:v>9.21</c:v>
                 </c:pt>
                 <c:pt idx="3">
-                  <c:v>11.3</c:v>
+                  <c:v>9.62</c:v>
                 </c:pt>
                 <c:pt idx="4">
-                  <c:v>13.38</c:v>
+                  <c:v>10.52</c:v>
                 </c:pt>
                 <c:pt idx="5">
-                  <c:v>15.63</c:v>
+                  <c:v>13.67</c:v>
                 </c:pt>
                 <c:pt idx="6">
-                  <c:v>15.63</c:v>
+                  <c:v>14.51</c:v>
                 </c:pt>
                 <c:pt idx="7">
-                  <c:v>16.62</c:v>
+                  <c:v>16.17</c:v>
                 </c:pt>
                 <c:pt idx="8">
-                  <c:v>16.74</c:v>
+                  <c:v>16.55</c:v>
                 </c:pt>
                 <c:pt idx="9">
-                  <c:v>17.71</c:v>
+                  <c:v>18.84</c:v>
                 </c:pt>
                 <c:pt idx="10">
-                  <c:v>19.04</c:v>
+                  <c:v>19.02</c:v>
                 </c:pt>
                 <c:pt idx="11">
-                  <c:v>19.5</c:v>
+                  <c:v>19.15</c:v>
                 </c:pt>
                 <c:pt idx="12">
-                  <c:v>19.59</c:v>
+                  <c:v>19.4</c:v>
                 </c:pt>
                 <c:pt idx="13">
-                  <c:v>19.77</c:v>
+                  <c:v>19.56</c:v>
                 </c:pt>
                 <c:pt idx="14">
-                  <c:v>20.04</c:v>
+                  <c:v>19.96</c:v>
                 </c:pt>
                 <c:pt idx="15">
-                  <c:v>21.19</c:v>
+                  <c:v>20.31</c:v>
                 </c:pt>
                 <c:pt idx="16">
-                  <c:v>22.35</c:v>
+                  <c:v>20.94</c:v>
                 </c:pt>
                 <c:pt idx="17">
-                  <c:v>22.7</c:v>
+                  <c:v>21.77</c:v>
                 </c:pt>
                 <c:pt idx="18">
-                  <c:v>23.01</c:v>
+                  <c:v>21.85</c:v>
                 </c:pt>
                 <c:pt idx="19">
-                  <c:v>23.11</c:v>
+                  <c:v>22.67</c:v>
                 </c:pt>
                 <c:pt idx="20">
-                  <c:v>23.83</c:v>
+                  <c:v>25.13</c:v>
                 </c:pt>
                 <c:pt idx="21">
-                  <c:v>24.24</c:v>
+                  <c:v>25.71</c:v>
                 </c:pt>
                 <c:pt idx="22">
-                  <c:v>24.82</c:v>
+                  <c:v>27.49</c:v>
                 </c:pt>
                 <c:pt idx="23">
-                  <c:v>26.7</c:v>
+                  <c:v>28.02</c:v>
                 </c:pt>
                 <c:pt idx="24">
-                  <c:v>28.15</c:v>
+                  <c:v>28.64</c:v>
                 </c:pt>
                 <c:pt idx="25">
-                  <c:v>29.92</c:v>
+                  <c:v>30.27</c:v>
                 </c:pt>
                 <c:pt idx="26">
-                  <c:v>31.11</c:v>
+                  <c:v>32.4</c:v>
                 </c:pt>
                 <c:pt idx="27">
-                  <c:v>31.93</c:v>
+                  <c:v>34.48</c:v>
                 </c:pt>
                 <c:pt idx="28">
-                  <c:v>32.47</c:v>
+                  <c:v>35.22</c:v>
+                </c:pt>
+                <c:pt idx="29">
+                  <c:v>35.76</c:v>
+                </c:pt>
+                <c:pt idx="30">
+                  <c:v>36.11</c:v>
+                </c:pt>
+                <c:pt idx="31">
+                  <c:v>36.85</c:v>
                 </c:pt>
               </c:numCache>
             </c:numRef>
           </c:xVal>
           <c:yVal>
             <c:numRef>
-              <c:f>'Chart Data'!$D$2:$D$30</c:f>
+              <c:f>Sheet1!$B$39:$B$70</c:f>
               <c:numCache>
-                <c:formatCode>0</c:formatCode>
-                <c:ptCount val="29"/>
+                <c:formatCode>General</c:formatCode>
+                <c:ptCount val="32"/>
                 <c:pt idx="0">
+                  <c:v>9.62</c:v>
+                </c:pt>
+                <c:pt idx="1">
+                  <c:v>9.54</c:v>
+                </c:pt>
+                <c:pt idx="2">
+                  <c:v>9.59</c:v>
+                </c:pt>
+                <c:pt idx="3">
                   <c:v>9.65</c:v>
                 </c:pt>
-                <c:pt idx="1">
-                  <c:v>9.65</c:v>
-                </c:pt>
-                <c:pt idx="2">
+                <c:pt idx="4">
                   <c:v>9.64</c:v>
                 </c:pt>
-                <c:pt idx="3">
-                  <c:v>8.87</c:v>
-                </c:pt>
-                <c:pt idx="4">
-                  <c:v>8.55</c:v>
-                </c:pt>
                 <c:pt idx="5">
-                  <c:v>8.52</c:v>
+                  <c:v>14.04</c:v>
                 </c:pt>
                 <c:pt idx="6">
-                  <c:v>8.79</c:v>
+                  <c:v>9.5</c:v>
                 </c:pt>
                 <c:pt idx="7">
-                  <c:v>8.79</c:v>
+                  <c:v>9.12</c:v>
                 </c:pt>
                 <c:pt idx="8">
-                  <c:v>13.88</c:v>
+                  <c:v>9.34</c:v>
                 </c:pt>
                 <c:pt idx="9">
-                  <c:v>21.83</c:v>
+                  <c:v>27.78</c:v>
                 </c:pt>
                 <c:pt idx="10">
-                  <c:v>25.12</c:v>
+                  <c:v>28.3</c:v>
                 </c:pt>
                 <c:pt idx="11">
-                  <c:v>26.78</c:v>
+                  <c:v>28.15</c:v>
                 </c:pt>
                 <c:pt idx="12">
-                  <c:v>27.62</c:v>
+                  <c:v>25.04</c:v>
                 </c:pt>
                 <c:pt idx="13">
-                  <c:v>27.11</c:v>
+                  <c:v>28.99</c:v>
                 </c:pt>
                 <c:pt idx="14">
-                  <c:v>27.78</c:v>
+                  <c:v>29.18</c:v>
                 </c:pt>
                 <c:pt idx="15">
-                  <c:v>28.17</c:v>
+                  <c:v>29.34</c:v>
                 </c:pt>
                 <c:pt idx="16">
-                  <c:v>28.23</c:v>
+                  <c:v>29.42</c:v>
                 </c:pt>
                 <c:pt idx="17">
-                  <c:v>28.23</c:v>
+                  <c:v>29.42</c:v>
                 </c:pt>
                 <c:pt idx="18">
-                  <c:v>28.23</c:v>
+                  <c:v>29.42</c:v>
                 </c:pt>
                 <c:pt idx="19">
-                  <c:v>28.23</c:v>
+                  <c:v>29.42</c:v>
                 </c:pt>
                 <c:pt idx="20">
-                  <c:v>28.16</c:v>
+                  <c:v>29.42</c:v>
                 </c:pt>
                 <c:pt idx="21">
-                  <c:v>28.23</c:v>
+                  <c:v>29.34</c:v>
                 </c:pt>
                 <c:pt idx="22">
-                  <c:v>28.23</c:v>
+                  <c:v>29.42</c:v>
                 </c:pt>
                 <c:pt idx="23">
-                  <c:v>28.23</c:v>
+                  <c:v>29.42</c:v>
                 </c:pt>
                 <c:pt idx="24">
-                  <c:v>28.23</c:v>
+                  <c:v>29.42</c:v>
                 </c:pt>
                 <c:pt idx="25">
-                  <c:v>28.23</c:v>
+                  <c:v>29.42</c:v>
                 </c:pt>
                 <c:pt idx="26">
-                  <c:v>28.23</c:v>
+                  <c:v>29.42</c:v>
                 </c:pt>
                 <c:pt idx="27">
-                  <c:v>28.23</c:v>
+                  <c:v>29.42</c:v>
                 </c:pt>
                 <c:pt idx="28">
-                  <c:v>28.23</c:v>
+                  <c:v>29.42</c:v>
+                </c:pt>
+                <c:pt idx="29">
+                  <c:v>29.42</c:v>
+                </c:pt>
+                <c:pt idx="30">
+                  <c:v>29.42</c:v>
+                </c:pt>
+                <c:pt idx="31">
+                  <c:v>29.42</c:v>
                 </c:pt>
               </c:numCache>
             </c:numRef>
@@ -3341,8 +3411,8 @@
         <c:axId val="48650112"/>
         <c:scaling>
           <c:orientation val="minMax"/>
-          <c:max val="35"/>
-          <c:min val="5"/>
+          <c:max val="40"/>
+          <c:min val="0"/>
         </c:scaling>
         <c:delete val="0"/>
         <c:axPos val="b"/>
@@ -3480,7 +3550,15 @@
           <c:idx val="0"/>
           <c:order val="0"/>
           <c:tx>
-            <c:v>Encode 38.20 ms</c:v>
+            <c:strRef>
+              <c:f>Sheet1!$B$1</c:f>
+              <c:strCache>
+                <c:ptCount val="1"/>
+                <c:pt idx="0">
+                  <c:v>Encode 38.20 ms</c:v>
+                </c:pt>
+              </c:strCache>
+            </c:strRef>
           </c:tx>
           <c:spPr>
             <a:solidFill xmlns:a="http://schemas.openxmlformats.org/drawingml/2006/main">
@@ -3502,7 +3580,7 @@
           </c:dLbls>
           <c:cat>
             <c:strRef>
-              <c:f>'Chart Data'!$A$2:$A$2</c:f>
+              <c:f>Sheet1!$A$2:$A$2</c:f>
               <c:strCache>
                 <c:ptCount val="1"/>
                 <c:pt idx="0">
@@ -3513,7 +3591,7 @@
           </c:cat>
           <c:val>
             <c:numRef>
-              <c:f>'Chart Data'!$B$2:$B$2</c:f>
+              <c:f>Sheet1!$B$2:$B$2</c:f>
               <c:numCache>
                 <c:formatCode>General</c:formatCode>
                 <c:ptCount val="1"/>
@@ -3528,7 +3606,15 @@
           <c:idx val="1"/>
           <c:order val="1"/>
           <c:tx>
-            <c:v>Transfer 2.87 ms</c:v>
+            <c:strRef>
+              <c:f>Sheet1!$C$1</c:f>
+              <c:strCache>
+                <c:ptCount val="1"/>
+                <c:pt idx="0">
+                  <c:v>Transfer 2.90 ms</c:v>
+                </c:pt>
+              </c:strCache>
+            </c:strRef>
           </c:tx>
           <c:spPr>
             <a:solidFill xmlns:a="http://schemas.openxmlformats.org/drawingml/2006/main">
@@ -3550,7 +3636,7 @@
           </c:dLbls>
           <c:cat>
             <c:strRef>
-              <c:f>'Chart Data'!$C$2:$C$2</c:f>
+              <c:f>Sheet1!$A$2:$A$2</c:f>
               <c:strCache>
                 <c:ptCount val="1"/>
                 <c:pt idx="0">
@@ -3561,12 +3647,12 @@
           </c:cat>
           <c:val>
             <c:numRef>
-              <c:f>'Chart Data'!$D$2:$D$2</c:f>
+              <c:f>Sheet1!$C$2:$C$2</c:f>
               <c:numCache>
                 <c:formatCode>General</c:formatCode>
                 <c:ptCount val="1"/>
                 <c:pt idx="0">
-                  <c:v>2.87</c:v>
+                  <c:v>2.9</c:v>
                 </c:pt>
               </c:numCache>
             </c:numRef>
@@ -3576,7 +3662,15 @@
           <c:idx val="2"/>
           <c:order val="2"/>
           <c:tx>
-            <c:v>Decode 30.39 ms</c:v>
+            <c:strRef>
+              <c:f>Sheet1!$D$1</c:f>
+              <c:strCache>
+                <c:ptCount val="1"/>
+                <c:pt idx="0">
+                  <c:v>Decode 26.39 ms</c:v>
+                </c:pt>
+              </c:strCache>
+            </c:strRef>
           </c:tx>
           <c:spPr>
             <a:solidFill xmlns:a="http://schemas.openxmlformats.org/drawingml/2006/main">
@@ -3598,7 +3692,7 @@
           </c:dLbls>
           <c:cat>
             <c:strRef>
-              <c:f>'Chart Data'!$E$2:$E$2</c:f>
+              <c:f>Sheet1!$A$2:$A$2</c:f>
               <c:strCache>
                 <c:ptCount val="1"/>
                 <c:pt idx="0">
@@ -3609,12 +3703,12 @@
           </c:cat>
           <c:val>
             <c:numRef>
-              <c:f>'Chart Data'!$F$2:$F$2</c:f>
+              <c:f>Sheet1!$D$2:$D$2</c:f>
               <c:numCache>
                 <c:formatCode>General</c:formatCode>
                 <c:ptCount val="1"/>
                 <c:pt idx="0">
-                  <c:v>30.39</c:v>
+                  <c:v>26.39</c:v>
                 </c:pt>
               </c:numCache>
             </c:numRef>
@@ -3811,6 +3905,10 @@
             <a:noFill/>
           </a:ln>
         </p:spPr>
+        <p:txBody xmlns:a="http://schemas.openxmlformats.org/drawingml/2006/main">
+          <a:bodyPr/>
+          <a:p/>
+        </p:txBody>
       </p:sp>
       <p:sp>
         <p:nvSpPr>
@@ -3843,6 +3941,10 @@
             <a:noFill/>
           </a:ln>
         </p:spPr>
+        <p:txBody xmlns:a="http://schemas.openxmlformats.org/drawingml/2006/main">
+          <a:bodyPr/>
+          <a:p/>
+        </p:txBody>
       </p:sp>
       <p:sp>
         <p:nvSpPr>
@@ -3875,6 +3977,10 @@
             <a:noFill/>
           </a:ln>
         </p:spPr>
+        <p:txBody xmlns:a="http://schemas.openxmlformats.org/drawingml/2006/main">
+          <a:bodyPr/>
+          <a:p/>
+        </p:txBody>
       </p:sp>
       <p:sp>
         <p:nvSpPr>
@@ -3907,6 +4013,10 @@
             <a:noFill/>
           </a:ln>
         </p:spPr>
+        <p:txBody xmlns:a="http://schemas.openxmlformats.org/drawingml/2006/main">
+          <a:bodyPr/>
+          <a:p/>
+        </p:txBody>
       </p:sp>
       <p:sp>
         <p:nvSpPr>
@@ -3939,6 +4049,10 @@
             <a:noFill/>
           </a:ln>
         </p:spPr>
+        <p:txBody xmlns:a="http://schemas.openxmlformats.org/drawingml/2006/main">
+          <a:bodyPr/>
+          <a:p/>
+        </p:txBody>
       </p:sp>
       <p:sp>
         <p:nvSpPr>
@@ -3971,6 +4085,10 @@
             <a:noFill/>
           </a:ln>
         </p:spPr>
+        <p:txBody xmlns:a="http://schemas.openxmlformats.org/drawingml/2006/main">
+          <a:bodyPr/>
+          <a:p/>
+        </p:txBody>
       </p:sp>
       <p:sp>
         <p:nvSpPr>
@@ -4003,6 +4121,10 @@
             <a:noFill/>
           </a:ln>
         </p:spPr>
+        <p:txBody xmlns:a="http://schemas.openxmlformats.org/drawingml/2006/main">
+          <a:bodyPr/>
+          <a:p/>
+        </p:txBody>
       </p:sp>
       <p:sp>
         <p:nvSpPr>
@@ -4035,6 +4157,10 @@
             <a:noFill/>
           </a:ln>
         </p:spPr>
+        <p:txBody xmlns:a="http://schemas.openxmlformats.org/drawingml/2006/main">
+          <a:bodyPr/>
+          <a:p/>
+        </p:txBody>
       </p:sp>
       <p:cxnSp>
         <p:nvCxnSpPr>
@@ -4758,7 +4884,7 @@
                 <a:ea typeface="Calibri"/>
                 <a:cs typeface="Calibri"/>
               </a:rPr>
-              <a:t>18,000 frames over 10 min</a:t>
+              <a:t>18,020 frames over 10 min</a:t>
             </a:r>
           </a:p>
         </p:txBody>
@@ -4826,7 +4952,7 @@
                 <a:ea typeface="Calibri"/>
                 <a:cs typeface="Calibri"/>
               </a:rPr>
-              <a:t>71.5 ms</a:t>
+              <a:t>67.5 ms</a:t>
             </a:r>
           </a:p>
         </p:txBody>
@@ -4985,7 +5111,7 @@
                 <a:ea typeface="Calibri"/>
                 <a:cs typeface="Calibri"/>
               </a:rPr>
-              <a:t>+3.8 dB</a:t>
+              <a:t>+2.8 dB</a:t>
             </a:r>
           </a:p>
         </p:txBody>
@@ -5435,6 +5561,10 @@
             </a:solidFill>
           </a:ln>
         </p:spPr>
+        <p:txBody xmlns:a="http://schemas.openxmlformats.org/drawingml/2006/main">
+          <a:bodyPr/>
+          <a:p/>
+        </p:txBody>
       </p:sp>
       <p:sp>
         <p:nvSpPr>
@@ -5603,6 +5733,10 @@
             </a:solidFill>
           </a:ln>
         </p:spPr>
+        <p:txBody xmlns:a="http://schemas.openxmlformats.org/drawingml/2006/main">
+          <a:bodyPr/>
+          <a:p/>
+        </p:txBody>
       </p:sp>
       <p:sp>
         <p:nvSpPr>
@@ -5771,6 +5905,10 @@
             </a:solidFill>
           </a:ln>
         </p:spPr>
+        <p:txBody xmlns:a="http://schemas.openxmlformats.org/drawingml/2006/main">
+          <a:bodyPr/>
+          <a:p/>
+        </p:txBody>
       </p:sp>
       <p:sp>
         <p:nvSpPr>
@@ -5939,6 +6077,10 @@
             </a:solidFill>
           </a:ln>
         </p:spPr>
+        <p:txBody xmlns:a="http://schemas.openxmlformats.org/drawingml/2006/main">
+          <a:bodyPr/>
+          <a:p/>
+        </p:txBody>
       </p:sp>
       <p:sp>
         <p:nvSpPr>
@@ -6107,6 +6249,10 @@
             </a:solidFill>
           </a:ln>
         </p:spPr>
+        <p:txBody xmlns:a="http://schemas.openxmlformats.org/drawingml/2006/main">
+          <a:bodyPr/>
+          <a:p/>
+        </p:txBody>
       </p:sp>
       <p:sp>
         <p:nvSpPr>
@@ -6275,6 +6421,10 @@
             </a:solidFill>
           </a:ln>
         </p:spPr>
+        <p:txBody xmlns:a="http://schemas.openxmlformats.org/drawingml/2006/main">
+          <a:bodyPr/>
+          <a:p/>
+        </p:txBody>
       </p:sp>
       <p:sp>
         <p:nvSpPr>
@@ -6443,6 +6593,10 @@
             </a:solidFill>
           </a:ln>
         </p:spPr>
+        <p:txBody xmlns:a="http://schemas.openxmlformats.org/drawingml/2006/main">
+          <a:bodyPr/>
+          <a:p/>
+        </p:txBody>
       </p:sp>
       <p:sp>
         <p:nvSpPr>
@@ -6611,6 +6765,10 @@
             </a:solidFill>
           </a:ln>
         </p:spPr>
+        <p:txBody xmlns:a="http://schemas.openxmlformats.org/drawingml/2006/main">
+          <a:bodyPr/>
+          <a:p/>
+        </p:txBody>
       </p:sp>
       <p:sp>
         <p:nvSpPr>
@@ -7084,7 +7242,7 @@
                 <a:ea typeface="Calibri"/>
                 <a:cs typeface="Calibri"/>
               </a:rPr>
-              <a:t>18,000 frames received in 600.06 s</a:t>
+              <a:t>18,020 frames received in 600 s</a:t>
             </a:r>
           </a:p>
         </p:txBody>
@@ -7243,7 +7401,7 @@
                 <a:ea typeface="Calibri"/>
                 <a:cs typeface="Calibri"/>
               </a:rPr>
-              <a:t>SSCC baseline: JPEG + convolutional code + 64-QAM</a:t>
+              <a:t>SSCC baseline: JPEG + 802.11n LDPC (rate 2/3) + 64-QAM</a:t>
             </a:r>
           </a:p>
         </p:txBody>
@@ -7565,7 +7723,7 @@
                 <a:ea typeface="Calibri"/>
                 <a:cs typeface="Calibri"/>
               </a:rPr>
-              <a:t>32.3 dB</a:t>
+              <a:t>36.1 dB</a:t>
             </a:r>
           </a:p>
         </p:txBody>
@@ -7633,7 +7791,7 @@
                 <a:ea typeface="Calibri"/>
                 <a:cs typeface="Calibri"/>
               </a:rPr>
-              <a:t>17.4 dB</a:t>
+              <a:t>14.2 dB</a:t>
             </a:r>
           </a:p>
         </p:txBody>
@@ -7701,7 +7859,7 @@
                 <a:ea typeface="Calibri"/>
                 <a:cs typeface="Calibri"/>
               </a:rPr>
-              <a:t>13.1 dB</a:t>
+              <a:t>10.5 dB</a:t>
             </a:r>
           </a:p>
         </p:txBody>
@@ -7769,7 +7927,7 @@
                 <a:ea typeface="Calibri"/>
                 <a:cs typeface="Calibri"/>
               </a:rPr>
-              <a:t>5.5 dB</a:t>
+              <a:t>2.9 dB</a:t>
             </a:r>
           </a:p>
         </p:txBody>
@@ -8001,7 +8159,7 @@
                 <a:ea typeface="Calibri"/>
                 <a:cs typeface="Calibri"/>
               </a:rPr>
-              <a:t>31.99 / 0.94</a:t>
+              <a:t>32.21 / 0.94</a:t>
             </a:r>
           </a:p>
         </p:txBody>
@@ -8097,7 +8255,7 @@
                 <a:ea typeface="Calibri"/>
                 <a:cs typeface="Calibri"/>
               </a:rPr>
-              <a:t>31.66 / 0.94</a:t>
+              <a:t>31.46 / 0.94</a:t>
             </a:r>
           </a:p>
         </p:txBody>
@@ -8193,7 +8351,7 @@
                 <a:ea typeface="Calibri"/>
                 <a:cs typeface="Calibri"/>
               </a:rPr>
-              <a:t>31.19 / 0.93</a:t>
+              <a:t>30.41 / 0.93</a:t>
             </a:r>
           </a:p>
         </p:txBody>
@@ -8289,7 +8447,7 @@
                 <a:ea typeface="Calibri"/>
                 <a:cs typeface="Calibri"/>
               </a:rPr>
-              <a:t>26.55 / 0.87</a:t>
+              <a:t>23.51 / 0.77</a:t>
             </a:r>
           </a:p>
         </p:txBody>
@@ -8385,7 +8543,7 @@
                 <a:ea typeface="Calibri"/>
                 <a:cs typeface="Calibri"/>
               </a:rPr>
-              <a:t>28.23 / 0.83</a:t>
+              <a:t>29.42 / 0.86</a:t>
             </a:r>
           </a:p>
         </p:txBody>
@@ -8481,7 +8639,7 @@
                 <a:ea typeface="Calibri"/>
                 <a:cs typeface="Calibri"/>
               </a:rPr>
-              <a:t>22.06 / 0.78</a:t>
+              <a:t>14.33 / 0.63</a:t>
             </a:r>
           </a:p>
         </p:txBody>
@@ -8577,7 +8735,7 @@
                 <a:ea typeface="Calibri"/>
                 <a:cs typeface="Calibri"/>
               </a:rPr>
-              <a:t>8.01 / 0.12</a:t>
+              <a:t>9.48 / 0.16</a:t>
             </a:r>
           </a:p>
         </p:txBody>
@@ -8611,6 +8769,10 @@
             <a:noFill/>
           </a:ln>
         </p:spPr>
+        <p:txBody xmlns:a="http://schemas.openxmlformats.org/drawingml/2006/main">
+          <a:bodyPr/>
+          <a:p/>
+        </p:txBody>
       </p:sp>
       <p:sp>
         <p:nvSpPr>
@@ -8834,7 +8996,7 @@
                 <a:ea typeface="Calibri"/>
                 <a:cs typeface="Calibri"/>
               </a:rPr>
-              <a:t>Matched TX attenuation; headings show the mean measured SNR of both schemes.</a:t>
+              <a:t>Matched TX attenuation; headings show the measured SNR of the DeepJSCC-Q frames.</a:t>
             </a:r>
           </a:p>
           <a:p xmlns:a="http://schemas.openxmlformats.org/drawingml/2006/main">
@@ -8993,7 +9155,7 @@
                 <a:ea typeface="Calibri"/>
                 <a:cs typeface="Calibri"/>
               </a:rPr>
-              <a:t>250 MHz, W8A12, 2.33 GMAC per frame</a:t>
+              <a:t>250 MHz, W8A12, 1.15 GMAC per frame</a:t>
             </a:r>
           </a:p>
         </p:txBody>
@@ -9029,6 +9191,10 @@
             </a:solidFill>
           </a:ln>
         </p:spPr>
+        <p:txBody xmlns:a="http://schemas.openxmlformats.org/drawingml/2006/main">
+          <a:bodyPr/>
+          <a:p/>
+        </p:txBody>
       </p:sp>
       <p:sp>
         <p:nvSpPr>
@@ -9197,6 +9363,10 @@
             </a:solidFill>
           </a:ln>
         </p:spPr>
+        <p:txBody xmlns:a="http://schemas.openxmlformats.org/drawingml/2006/main">
+          <a:bodyPr/>
+          <a:p/>
+        </p:txBody>
       </p:sp>
       <p:sp>
         <p:nvSpPr>
@@ -9365,6 +9535,10 @@
             </a:solidFill>
           </a:ln>
         </p:spPr>
+        <p:txBody xmlns:a="http://schemas.openxmlformats.org/drawingml/2006/main">
+          <a:bodyPr/>
+          <a:p/>
+        </p:txBody>
       </p:sp>
       <p:sp>
         <p:nvSpPr>
@@ -9533,6 +9707,10 @@
             </a:solidFill>
           </a:ln>
         </p:spPr>
+        <p:txBody xmlns:a="http://schemas.openxmlformats.org/drawingml/2006/main">
+          <a:bodyPr/>
+          <a:p/>
+        </p:txBody>
       </p:sp>
       <p:sp>
         <p:nvSpPr>
@@ -9701,6 +9879,10 @@
             </a:solidFill>
           </a:ln>
         </p:spPr>
+        <p:txBody xmlns:a="http://schemas.openxmlformats.org/drawingml/2006/main">
+          <a:bodyPr/>
+          <a:p/>
+        </p:txBody>
       </p:sp>
       <p:sp>
         <p:nvSpPr>
@@ -10238,7 +10420,7 @@
                           <a:ea typeface="Calibri"/>
                           <a:cs typeface="Calibri"/>
                         </a:rPr>
-                        <a:t>52,679</a:t>
+                        <a:t>54,246</a:t>
                       </a:r>
                     </a:p>
                   </a:txBody>
@@ -10431,7 +10613,7 @@
                           <a:ea typeface="Calibri"/>
                           <a:cs typeface="Calibri"/>
                         </a:rPr>
-                        <a:t>70,768</a:t>
+                        <a:t>63,691</a:t>
                       </a:r>
                     </a:p>
                   </a:txBody>
@@ -10468,7 +10650,7 @@
                           <a:ea typeface="Calibri"/>
                           <a:cs typeface="Calibri"/>
                         </a:rPr>
-                        <a:t>123.5</a:t>
+                        <a:t>65.5</a:t>
                       </a:r>
                     </a:p>
                   </a:txBody>
@@ -10505,7 +10687,7 @@
                           <a:ea typeface="Calibri"/>
                           <a:cs typeface="Calibri"/>
                         </a:rPr>
-                        <a:t>25</a:t>
+                        <a:t>7</a:t>
                       </a:r>
                     </a:p>
                   </a:txBody>
@@ -10542,7 +10724,7 @@
                           <a:ea typeface="Calibri"/>
                           <a:cs typeface="Calibri"/>
                         </a:rPr>
-                        <a:t>394</a:t>
+                        <a:t>133</a:t>
                       </a:r>
                     </a:p>
                   </a:txBody>
@@ -10632,7 +10814,7 @@
                 <a:ea typeface="Calibri"/>
                 <a:cs typeface="Calibri"/>
               </a:rPr>
-              <a:t>Measured rails: TX 3.06 W / RX 3.71 W</a:t>
+              <a:t>Measured rails: TX 3.07 W / RX 3.44 W</a:t>
             </a:r>
           </a:p>
           <a:p xmlns:a="http://schemas.openxmlformats.org/drawingml/2006/main">
@@ -10723,7 +10905,7 @@
                 <a:ea typeface="Calibri"/>
                 <a:cs typeface="Calibri"/>
               </a:rPr>
-              <a:t>PL frame latency: 71.5 ms</a:t>
+              <a:t>PL frame latency: 67.5 ms</a:t>
             </a:r>
           </a:p>
         </p:txBody>

</xml_diff>